<commit_message>
Refresh defense evidence compaction metrics
Co-authored-by: Copilot App <223556219+Copilot@users.noreply.github.com>
</commit_message>
<xml_diff>
--- a/docs/defense-deck/video-ai-poc-defense.pptx
+++ b/docs/defense-deck/video-ai-poc-defense.pptx
@@ -29180,7 +29180,7 @@
                 <a:ea typeface="Microsoft YaHei" pitchFamily="34" charset="-122"/>
                 <a:cs typeface="Microsoft YaHei" pitchFamily="34" charset="-120"/>
               </a:rPr>
-              <a:t>在覆盖 6 个事件窗、约 5 分钟时间轴的代表性自动化测试中，LLM 证据序列化从 8,636 个字符的压缩 JSON 降至 3,835 个字符的紧凑表格化证据，减少 55.6%。</a:t>
+              <a:t>在覆盖 6 个事件窗、约 5 分钟时间轴的代表性自动化测试中，LLM 证据序列化从 8,636 个字符的压缩 JSON 降至 3,878 个字符的紧凑表格化证据，减少 55.1%。</a:t>
             </a:r>
             <a:endParaRPr lang="en-US" sz="1250" dirty="0"/>
           </a:p>
@@ -30880,7 +30880,7 @@
                 </a:solidFill>
                 <a:latin typeface="Segoe UI Semibold"/>
               </a:rPr>
-              <a:t>55.6%</a:t>
+              <a:t>55.1%</a:t>
             </a:r>
           </a:p>
         </p:txBody>
@@ -30948,7 +30948,7 @@
               </a:rPr>
               <a:t>8,636
 →
-3,835</a:t>
+3,878</a:t>
             </a:r>
           </a:p>
         </p:txBody>
@@ -31014,7 +31014,7 @@
                 </a:solidFill>
                 <a:latin typeface="Segoe UI Semibold"/>
               </a:rPr>
-              <a:t>After — compact TSV (CSV-style) · 3,835 chars</a:t>
+              <a:t>After — compact TSV (CSV-style) · 3,878 chars</a:t>
             </a:r>
           </a:p>
         </p:txBody>

</xml_diff>